<commit_message>
fix(r26): deck 201 QA repairs — voice ban-tier 0, code clipping (5/8/11/23), divider 19 + bullet 24 overflow, captions
</commit_message>
<xml_diff>
--- a/presentation/csharp-design-patterns-201-idiomatic-csharp.pptx
+++ b/presentation/csharp-design-patterns-201-idiomatic-csharp.pptx
@@ -711,7 +711,7 @@
           <a:p>
             <a:r>
               <a:rPr lang="en-US" dirty="0"/>
-              <a:t>PaginateIterator is the method the compiler actually rewrites into a state machine: every local variable, the buffer, the page number, and the position in the foreach loop, becomes a field on a compiler-generated class that implements IEnumerable&lt;TrackingPage&gt; and IEnumerator&lt;TrackingPage&gt;. Each yield return suspends execution and hands one TrackingPage back to the caller; the next MoveNext call resumes exactly where the method left off, buffer and all. Paginate itself is deliberately not an iterator method: it validates pageSize synchronously and returns the call to PaginateIterator, so a caller sees the exception immediately rather than on the first enumeration.</a:t>
+              <a:t>PaginateIterator is the method the compiler actually rewrites into a state machine: every local variable, the buffer, the page number, and the position in the foreach loop, becomes a field on a compiler-generated class that implements IEnumerable&lt;TrackingPage&gt; and IEnumerator&lt;TrackingPage&gt;. Each yield return suspends execution and hands one TrackingPage back to the caller; the next MoveNext call resumes exactly where the method left off, buffer and all. Paginate itself is not an iterator method: it validates pageSize synchronously and returns the call to PaginateIterator, so a caller sees the exception immediately rather than on the first enumeration.</a:t>
             </a:r>
             <a:endParaRPr lang="en-US" dirty="0"/>
           </a:p>
@@ -1591,7 +1591,7 @@
           <a:p>
             <a:r>
               <a:rPr lang="en-US" dirty="0"/>
-              <a:t>CarrierShipment stands in for a third-party carrier SDK type this codebase cannot modify: sealed, constructor and read-only properties only, owned by a vendor. The two extension blocks let CarrierShipmentExtensions add an instance-shaped surface and a static surface to that type without ever touching its source again, and because the vendor type has no setters, WithAddedWeight returns an entirely new CarrierShipment rather than mutating anything. The classic this-parameter extension method, NormalisedDestination, still earns its keep for a single standalone method; the newer extension block syntax pays off once several related members, including an operator, need to live together against the same receiver.</a:t>
+              <a:t>CarrierShipment stands in for a third-party carrier SDK type this codebase cannot modify: sealed, constructor and read-only properties only, owned by a vendor. The two extension blocks let CarrierShipmentExtensions add an instance-shaped surface and a static surface to that type without ever touching its source again, and because the vendor type has no setters, WithAddedWeight returns an entirely new CarrierShipment rather than mutating anything. The classic this-parameter extension method, NormalisedDestination, still works well for a single standalone method; the newer extension block syntax pays off once several related members, including an operator, need to live together against the same receiver.</a:t>
             </a:r>
             <a:endParaRPr lang="en-US" dirty="0"/>
           </a:p>
@@ -2471,7 +2471,7 @@
           <a:p>
             <a:r>
               <a:rPr lang="en-US" dirty="0"/>
-              <a:t>A readonly record struct is the right shape for a quantity that should behave like a number: assigning it copies it, comparing two instances compares their values, and the compiler writes the equality members so nobody hand-rolls them. The catch every struct carries is the implicit parameterless default every .NET struct gets for free, which bypasses every constructor and every validation a type's own constructor performs; Money answers that by publishing its own safe Money.Zero rather than asking every caller to remember the trap. EdiRecordParser is a readonly ref struct specifically because only a ref struct may hold a ReadOnlySpan&lt;char&gt; field, and that restriction is also what keeps every instance stack-only and forces the parsing to stay synchronous and non-capturing.</a:t>
+              <a:t>A readonly record struct is the right shape for a quantity that should behave like a number: assigning it copies it, comparing two instances compares their values, and the compiler writes the equality members so nobody hand-rolls them. The catch every struct carries is the implicit parameterless default every .NET struct has, which bypasses every constructor and every validation a type's own constructor performs; Money answers that by publishing its own safe Money.Zero rather than asking every caller to remember the trap. EdiRecordParser is a readonly ref struct specifically because only a ref struct may hold a ReadOnlySpan&lt;char&gt; field, and that restriction is also what keeps every instance stack-only and forces the parsing to stay synchronous and non-capturing.</a:t>
             </a:r>
             <a:endParaRPr lang="en-US" dirty="0"/>
           </a:p>
@@ -2559,7 +2559,7 @@
           <a:p>
             <a:r>
               <a:rPr lang="en-US" dirty="0"/>
-              <a:t>The self-constraint on IRateable&lt;TSelf&gt; is what makes RateOf callable through a bare type parameter: it tells the compiler that any T satisfying IRateable&lt;T&gt; also supplies a static RateOf(T) member, so Quote&lt;T&gt; can call T.RateOf(shipment) with the JIT specializing the call per concrete value-type T rather than paying a virtual-dispatch cost. Money's interface list is what lets it plug into any algorithm written against the BCL's generic math interfaces without that algorithm knowing Money exists; AdditiveIdentity in particular gives a generic summation a correct starting point to fold from instead of an arbitrary literal zero that might not even be the right type. This Money is deliberately minimal, one Amount field with no currency, which keeps the generic math interfaces themselves the entire point of the example rather than mixing in the validation and currency concerns a production Money type would carry.</a:t>
+              <a:t>The self-constraint on IRateable&lt;TSelf&gt; is what makes RateOf callable through a bare type parameter: it tells the compiler that any T satisfying IRateable&lt;T&gt; also supplies a static RateOf(T) member, so Quote&lt;T&gt; can call T.RateOf(shipment) with the JIT specializing the call per concrete value-type T rather than paying a virtual-dispatch cost. Money's interface list is what lets it plug into any algorithm written against the BCL's generic math interfaces without that algorithm knowing Money exists; AdditiveIdentity in particular gives a generic summation a correct starting point to fold from instead of an arbitrary literal zero that might not even be the right type. This Money is minimal, one Amount field with no currency, which keeps the generic math interfaces themselves the entire point of the example rather than mixing in the validation and currency concerns a production Money type would carry.</a:t>
             </a:r>
             <a:endParaRPr lang="en-US" dirty="0"/>
           </a:p>
@@ -3175,7 +3175,7 @@
           <a:p>
             <a:r>
               <a:rPr lang="en-US" dirty="0"/>
-              <a:t>Consignment is a non-positional record class: every property is declared explicitly with required and init rather than through a primary constructor, so construction and later amendment read as two separate concerns. required is specifically the piece nullable reference types cannot enforce: a non-nullable property without it can still be left unassigned, with only a compiler warning to catch it, while a required property makes an incomplete object initializer a compile error. A 1994-era object model had no type-level way to mark a reference as never-absent, which is part of why a do-nothing stand-in object was the only safe shape for a legitimately missing value; here string? ReferenceNumber says plainly that absence is expected and lets the compiler's flow analysis catch an unchecked read.</a:t>
+              <a:t>Consignment is a non-positional record class: every property is declared explicitly with required and init rather than through a primary constructor, so construction and later amendment read as two separate concerns. required is specifically the piece nullable reference types cannot enforce: a non-nullable property without it can still be left unassigned, with only a compiler warning to catch it, while a required property makes an incomplete object initializer a compile error. A 1994-era object model had no type-level way to mark a reference as never-absent, which is part of why a do-nothing stand-in object was the only safe shape for a legitimately missing value; here string? ReferenceNumber states that absence is expected and lets the compiler's flow analysis catch an unchecked read.</a:t>
             </a:r>
             <a:endParaRPr lang="en-US" dirty="0"/>
           </a:p>
@@ -4529,8 +4529,8 @@
         </p:nvSpPr>
         <p:spPr>
           <a:xfrm>
-            <a:off x="566928" y="1691640"/>
-            <a:ext cx="11055096" cy="4251960"/>
+            <a:off x="566928" y="1572768"/>
+            <a:ext cx="11055096" cy="4526280"/>
           </a:xfrm>
           <a:prstGeom prst="rect">
             <a:avLst/>
@@ -4554,8 +4554,8 @@
         </p:nvSpPr>
         <p:spPr>
           <a:xfrm>
-            <a:off x="749808" y="1783080"/>
-            <a:ext cx="10689336" cy="4069080"/>
+            <a:off x="749808" y="1664208"/>
+            <a:ext cx="10689336" cy="4343400"/>
           </a:xfrm>
           <a:prstGeom prst="rect">
             <a:avLst/>
@@ -4574,7 +4574,7 @@
               <a:buNone/>
             </a:pPr>
             <a:r>
-              <a:rPr lang="en-US" sz="1100" dirty="0">
+              <a:rPr lang="en-US" sz="900" dirty="0">
                 <a:solidFill>
                   <a:srgbClr val="E6E6E6"/>
                 </a:solidFill>
@@ -4592,7 +4592,7 @@
               <a:buNone/>
             </a:pPr>
             <a:r>
-              <a:rPr lang="en-US" sz="1100" dirty="0">
+              <a:rPr lang="en-US" sz="900" dirty="0">
                 <a:solidFill>
                   <a:srgbClr val="E6E6E6"/>
                 </a:solidFill>
@@ -4610,7 +4610,7 @@
               <a:buNone/>
             </a:pPr>
             <a:r>
-              <a:rPr lang="en-US" sz="1100" dirty="0">
+              <a:rPr lang="en-US" sz="900" dirty="0">
                 <a:solidFill>
                   <a:srgbClr val="E6E6E6"/>
                 </a:solidFill>
@@ -4628,7 +4628,7 @@
               <a:buNone/>
             </a:pPr>
             <a:r>
-              <a:rPr lang="en-US" sz="1100" dirty="0">
+              <a:rPr lang="en-US" sz="900" dirty="0">
                 <a:solidFill>
                   <a:srgbClr val="E6E6E6"/>
                 </a:solidFill>
@@ -4646,7 +4646,7 @@
               <a:buNone/>
             </a:pPr>
             <a:r>
-              <a:rPr lang="en-US" sz="1100" dirty="0">
+              <a:rPr lang="en-US" sz="900" dirty="0">
                 <a:solidFill>
                   <a:srgbClr val="E6E6E6"/>
                 </a:solidFill>
@@ -4664,7 +4664,7 @@
               <a:buNone/>
             </a:pPr>
             <a:r>
-              <a:rPr lang="en-US" sz="1100" dirty="0">
+              <a:rPr lang="en-US" sz="900" dirty="0">
                 <a:solidFill>
                   <a:srgbClr val="E6E6E6"/>
                 </a:solidFill>
@@ -4682,7 +4682,7 @@
               <a:buNone/>
             </a:pPr>
             <a:r>
-              <a:rPr lang="en-US" sz="1100" dirty="0">
+              <a:rPr lang="en-US" sz="900" dirty="0">
                 <a:solidFill>
                   <a:srgbClr val="E6E6E6"/>
                 </a:solidFill>
@@ -4700,7 +4700,7 @@
               <a:buNone/>
             </a:pPr>
             <a:r>
-              <a:rPr lang="en-US" sz="1100" dirty="0">
+              <a:rPr lang="en-US" sz="900" dirty="0">
                 <a:solidFill>
                   <a:srgbClr val="E6E6E6"/>
                 </a:solidFill>
@@ -4718,7 +4718,7 @@
               <a:buNone/>
             </a:pPr>
             <a:r>
-              <a:rPr lang="en-US" sz="1100" dirty="0">
+              <a:rPr lang="en-US" sz="900" dirty="0">
                 <a:solidFill>
                   <a:srgbClr val="E6E6E6"/>
                 </a:solidFill>
@@ -4736,7 +4736,7 @@
               <a:buNone/>
             </a:pPr>
             <a:r>
-              <a:rPr lang="en-US" sz="1100" dirty="0">
+              <a:rPr lang="en-US" sz="900" dirty="0">
                 <a:solidFill>
                   <a:srgbClr val="E6E6E6"/>
                 </a:solidFill>
@@ -4754,7 +4754,7 @@
               <a:buNone/>
             </a:pPr>
             <a:r>
-              <a:rPr lang="en-US" sz="1100" dirty="0">
+              <a:rPr lang="en-US" sz="900" dirty="0">
                 <a:solidFill>
                   <a:srgbClr val="E6E6E6"/>
                 </a:solidFill>
@@ -4772,7 +4772,7 @@
               <a:buNone/>
             </a:pPr>
             <a:r>
-              <a:rPr lang="en-US" sz="1100" dirty="0">
+              <a:rPr lang="en-US" sz="900" dirty="0">
                 <a:solidFill>
                   <a:srgbClr val="E6E6E6"/>
                 </a:solidFill>
@@ -4790,7 +4790,7 @@
               <a:buNone/>
             </a:pPr>
             <a:r>
-              <a:rPr lang="en-US" sz="1100" dirty="0">
+              <a:rPr lang="en-US" sz="900" dirty="0">
                 <a:solidFill>
                   <a:srgbClr val="E6E6E6"/>
                 </a:solidFill>
@@ -4808,7 +4808,7 @@
               <a:buNone/>
             </a:pPr>
             <a:r>
-              <a:rPr lang="en-US" sz="1100" dirty="0">
+              <a:rPr lang="en-US" sz="900" dirty="0">
                 <a:solidFill>
                   <a:srgbClr val="E6E6E6"/>
                 </a:solidFill>
@@ -4826,7 +4826,7 @@
               <a:buNone/>
             </a:pPr>
             <a:r>
-              <a:rPr lang="en-US" sz="1100" dirty="0">
+              <a:rPr lang="en-US" sz="900" dirty="0">
                 <a:solidFill>
                   <a:srgbClr val="E6E6E6"/>
                 </a:solidFill>
@@ -4844,7 +4844,7 @@
               <a:buNone/>
             </a:pPr>
             <a:r>
-              <a:rPr lang="en-US" sz="1100" dirty="0">
+              <a:rPr lang="en-US" sz="900" dirty="0">
                 <a:solidFill>
                   <a:srgbClr val="E6E6E6"/>
                 </a:solidFill>
@@ -4862,7 +4862,7 @@
               <a:buNone/>
             </a:pPr>
             <a:r>
-              <a:rPr lang="en-US" sz="1100" dirty="0">
+              <a:rPr lang="en-US" sz="900" dirty="0">
                 <a:solidFill>
                   <a:srgbClr val="E6E6E6"/>
                 </a:solidFill>
@@ -4880,7 +4880,7 @@
               <a:buNone/>
             </a:pPr>
             <a:r>
-              <a:rPr lang="en-US" sz="1100" dirty="0">
+              <a:rPr lang="en-US" sz="900" dirty="0">
                 <a:solidFill>
                   <a:srgbClr val="E6E6E6"/>
                 </a:solidFill>
@@ -4898,7 +4898,7 @@
               <a:buNone/>
             </a:pPr>
             <a:r>
-              <a:rPr lang="en-US" sz="1100" dirty="0">
+              <a:rPr lang="en-US" sz="900" dirty="0">
                 <a:solidFill>
                   <a:srgbClr val="E6E6E6"/>
                 </a:solidFill>
@@ -4916,7 +4916,7 @@
               <a:buNone/>
             </a:pPr>
             <a:r>
-              <a:rPr lang="en-US" sz="1100" dirty="0">
+              <a:rPr lang="en-US" sz="900" dirty="0">
                 <a:solidFill>
                   <a:srgbClr val="E6E6E6"/>
                 </a:solidFill>
@@ -4934,7 +4934,7 @@
               <a:buNone/>
             </a:pPr>
             <a:r>
-              <a:rPr lang="en-US" sz="1100" dirty="0">
+              <a:rPr lang="en-US" sz="900" dirty="0">
                 <a:solidFill>
                   <a:srgbClr val="E6E6E6"/>
                 </a:solidFill>
@@ -4952,7 +4952,7 @@
               <a:buNone/>
             </a:pPr>
             <a:r>
-              <a:rPr lang="en-US" sz="1100" dirty="0">
+              <a:rPr lang="en-US" sz="900" dirty="0">
                 <a:solidFill>
                   <a:srgbClr val="E6E6E6"/>
                 </a:solidFill>
@@ -4970,7 +4970,7 @@
               <a:buNone/>
             </a:pPr>
             <a:r>
-              <a:rPr lang="en-US" sz="1100" dirty="0">
+              <a:rPr lang="en-US" sz="900" dirty="0">
                 <a:solidFill>
                   <a:srgbClr val="E6E6E6"/>
                 </a:solidFill>
@@ -4988,7 +4988,7 @@
               <a:buNone/>
             </a:pPr>
             <a:r>
-              <a:rPr lang="en-US" sz="1100" dirty="0">
+              <a:rPr lang="en-US" sz="900" dirty="0">
                 <a:solidFill>
                   <a:srgbClr val="E6E6E6"/>
                 </a:solidFill>
@@ -5006,7 +5006,7 @@
               <a:buNone/>
             </a:pPr>
             <a:r>
-              <a:rPr lang="en-US" sz="1100" dirty="0">
+              <a:rPr lang="en-US" sz="900" dirty="0">
                 <a:solidFill>
                   <a:srgbClr val="E6E6E6"/>
                 </a:solidFill>
@@ -5024,7 +5024,7 @@
               <a:buNone/>
             </a:pPr>
             <a:r>
-              <a:rPr lang="en-US" sz="1100" dirty="0">
+              <a:rPr lang="en-US" sz="900" dirty="0">
                 <a:solidFill>
                   <a:srgbClr val="E6E6E6"/>
                 </a:solidFill>
@@ -5042,7 +5042,7 @@
               <a:buNone/>
             </a:pPr>
             <a:r>
-              <a:rPr lang="en-US" sz="1100" dirty="0">
+              <a:rPr lang="en-US" sz="900" dirty="0">
                 <a:solidFill>
                   <a:srgbClr val="E6E6E6"/>
                 </a:solidFill>
@@ -5060,7 +5060,7 @@
               <a:buNone/>
             </a:pPr>
             <a:r>
-              <a:rPr lang="en-US" sz="1100" dirty="0">
+              <a:rPr lang="en-US" sz="900" dirty="0">
                 <a:solidFill>
                   <a:srgbClr val="E6E6E6"/>
                 </a:solidFill>
@@ -5078,7 +5078,7 @@
               <a:buNone/>
             </a:pPr>
             <a:r>
-              <a:rPr lang="en-US" sz="1100" dirty="0">
+              <a:rPr lang="en-US" sz="900" dirty="0">
                 <a:solidFill>
                   <a:srgbClr val="E6E6E6"/>
                 </a:solidFill>
@@ -5096,7 +5096,7 @@
               <a:buNone/>
             </a:pPr>
             <a:r>
-              <a:rPr lang="en-US" sz="1100" dirty="0">
+              <a:rPr lang="en-US" sz="900" dirty="0">
                 <a:solidFill>
                   <a:srgbClr val="E6E6E6"/>
                 </a:solidFill>
@@ -5114,7 +5114,7 @@
               <a:buNone/>
             </a:pPr>
             <a:r>
-              <a:rPr lang="en-US" sz="1100" dirty="0">
+              <a:rPr lang="en-US" sz="900" dirty="0">
                 <a:solidFill>
                   <a:srgbClr val="E6E6E6"/>
                 </a:solidFill>
@@ -5132,7 +5132,7 @@
               <a:buNone/>
             </a:pPr>
             <a:r>
-              <a:rPr lang="en-US" sz="1100" dirty="0">
+              <a:rPr lang="en-US" sz="900" dirty="0">
                 <a:solidFill>
                   <a:srgbClr val="E6E6E6"/>
                 </a:solidFill>
@@ -5143,7 +5143,7 @@
               <a:t>}
 </a:t>
             </a:r>
-            <a:endParaRPr lang="en-US" sz="1100" dirty="0"/>
+            <a:endParaRPr lang="en-US" sz="900" dirty="0"/>
           </a:p>
         </p:txBody>
       </p:sp>
@@ -5155,7 +5155,7 @@
         </p:nvSpPr>
         <p:spPr>
           <a:xfrm>
-            <a:off x="566928" y="5943600"/>
+            <a:off x="566928" y="6153912"/>
             <a:ext cx="11055096" cy="310896"/>
           </a:xfrm>
           <a:prstGeom prst="rect">
@@ -5834,7 +5834,7 @@
                 <a:ea typeface="Red Hat Text" pitchFamily="34" charset="-122"/>
                 <a:cs typeface="Red Hat Text" pitchFamily="34" charset="-120"/>
               </a:rPr>
-              <a:t>[EnumeratorCancellation] lets .WithCancellation(token) reach the iterator's own cancellationToken parameter instead of a default, uncancellable token.</a:t>
+              <a:t>[EnumeratorCancellation] lets .WithCancellation(token) reach the iterator's own cancellationToken instead of a default token.</a:t>
             </a:r>
             <a:endParaRPr lang="en-US" sz="1300" dirty="0"/>
           </a:p>
@@ -7123,7 +7123,7 @@
                 <a:ea typeface="Red Hat Text" pitchFamily="34" charset="-122"/>
                 <a:cs typeface="Red Hat Text" pitchFamily="34" charset="-120"/>
               </a:rPr>
-              <a:t>Result&lt;T&gt; carries either a value or a named Error and composes through Map, so a chain of operations never branches on IsSuccess by hand; ArgumentNullException.ThrowIfNull still guards a genuinely broken contract.</a:t>
+              <a:t>Result&lt;T&gt; carries either a value or a named Error and composes through Map, so a chain of operations never branches on IsSuccess by hand; ArgumentNullException.ThrowIfNull still guards a broken contract.</a:t>
             </a:r>
             <a:endParaRPr lang="en-US" sz="1550" dirty="0"/>
           </a:p>
@@ -8591,7 +8591,7 @@
                 <a:ea typeface="Overpass" pitchFamily="34" charset="-122"/>
                 <a:cs typeface="Overpass" pitchFamily="34" charset="-120"/>
               </a:rPr>
-              <a:t>C# as Data: Extend, Inspect, Generate, Enforce</a:t>
+              <a:t>C# as Data</a:t>
             </a:r>
             <a:endParaRPr lang="en-US" sz="4400" dirty="0"/>
           </a:p>
@@ -8630,7 +8630,7 @@
                 <a:ea typeface="Red Hat Text" pitchFamily="34" charset="-122"/>
                 <a:cs typeface="Red Hat Text" pitchFamily="34" charset="-120"/>
               </a:rPr>
-              <a:t>Treat code itself as a value the compiler can reason about</a:t>
+              <a:t>Extend, inspect, generate, enforce: treat code itself as a value the compiler can reason about</a:t>
             </a:r>
             <a:endParaRPr lang="en-US" sz="1600" dirty="0"/>
           </a:p>
@@ -10422,8 +10422,8 @@
         </p:nvSpPr>
         <p:spPr>
           <a:xfrm>
-            <a:off x="566928" y="1691640"/>
-            <a:ext cx="11055096" cy="4251960"/>
+            <a:off x="566928" y="1572768"/>
+            <a:ext cx="11055096" cy="4526280"/>
           </a:xfrm>
           <a:prstGeom prst="rect">
             <a:avLst/>
@@ -10447,8 +10447,8 @@
         </p:nvSpPr>
         <p:spPr>
           <a:xfrm>
-            <a:off x="749808" y="1783080"/>
-            <a:ext cx="10689336" cy="4069080"/>
+            <a:off x="749808" y="1664208"/>
+            <a:ext cx="10689336" cy="4343400"/>
           </a:xfrm>
           <a:prstGeom prst="rect">
             <a:avLst/>
@@ -10467,7 +10467,7 @@
               <a:buNone/>
             </a:pPr>
             <a:r>
-              <a:rPr lang="en-US" sz="1100" dirty="0">
+              <a:rPr lang="en-US" sz="1000" dirty="0">
                 <a:solidFill>
                   <a:srgbClr val="E6E6E6"/>
                 </a:solidFill>
@@ -10485,7 +10485,7 @@
               <a:buNone/>
             </a:pPr>
             <a:r>
-              <a:rPr lang="en-US" sz="1100" dirty="0">
+              <a:rPr lang="en-US" sz="1000" dirty="0">
                 <a:solidFill>
                   <a:srgbClr val="E6E6E6"/>
                 </a:solidFill>
@@ -10503,7 +10503,7 @@
               <a:buNone/>
             </a:pPr>
             <a:r>
-              <a:rPr lang="en-US" sz="1100" dirty="0">
+              <a:rPr lang="en-US" sz="1000" dirty="0">
                 <a:solidFill>
                   <a:srgbClr val="E6E6E6"/>
                 </a:solidFill>
@@ -10521,7 +10521,7 @@
               <a:buNone/>
             </a:pPr>
             <a:r>
-              <a:rPr lang="en-US" sz="1100" dirty="0">
+              <a:rPr lang="en-US" sz="1000" dirty="0">
                 <a:solidFill>
                   <a:srgbClr val="E6E6E6"/>
                 </a:solidFill>
@@ -10539,7 +10539,7 @@
               <a:buNone/>
             </a:pPr>
             <a:r>
-              <a:rPr lang="en-US" sz="1100" dirty="0">
+              <a:rPr lang="en-US" sz="1000" dirty="0">
                 <a:solidFill>
                   <a:srgbClr val="E6E6E6"/>
                 </a:solidFill>
@@ -10557,7 +10557,7 @@
               <a:buNone/>
             </a:pPr>
             <a:r>
-              <a:rPr lang="en-US" sz="1100" dirty="0">
+              <a:rPr lang="en-US" sz="1000" dirty="0">
                 <a:solidFill>
                   <a:srgbClr val="E6E6E6"/>
                 </a:solidFill>
@@ -10575,7 +10575,7 @@
               <a:buNone/>
             </a:pPr>
             <a:r>
-              <a:rPr lang="en-US" sz="1100" dirty="0">
+              <a:rPr lang="en-US" sz="1000" dirty="0">
                 <a:solidFill>
                   <a:srgbClr val="E6E6E6"/>
                 </a:solidFill>
@@ -10593,7 +10593,7 @@
               <a:buNone/>
             </a:pPr>
             <a:r>
-              <a:rPr lang="en-US" sz="1100" dirty="0">
+              <a:rPr lang="en-US" sz="1000" dirty="0">
                 <a:solidFill>
                   <a:srgbClr val="E6E6E6"/>
                 </a:solidFill>
@@ -10611,7 +10611,7 @@
               <a:buNone/>
             </a:pPr>
             <a:r>
-              <a:rPr lang="en-US" sz="1100" dirty="0">
+              <a:rPr lang="en-US" sz="1000" dirty="0">
                 <a:solidFill>
                   <a:srgbClr val="E6E6E6"/>
                 </a:solidFill>
@@ -10629,7 +10629,7 @@
               <a:buNone/>
             </a:pPr>
             <a:r>
-              <a:rPr lang="en-US" sz="1100" dirty="0">
+              <a:rPr lang="en-US" sz="1000" dirty="0">
                 <a:solidFill>
                   <a:srgbClr val="E6E6E6"/>
                 </a:solidFill>
@@ -10647,7 +10647,7 @@
               <a:buNone/>
             </a:pPr>
             <a:r>
-              <a:rPr lang="en-US" sz="1100" dirty="0">
+              <a:rPr lang="en-US" sz="1000" dirty="0">
                 <a:solidFill>
                   <a:srgbClr val="E6E6E6"/>
                 </a:solidFill>
@@ -10665,7 +10665,7 @@
               <a:buNone/>
             </a:pPr>
             <a:r>
-              <a:rPr lang="en-US" sz="1100" dirty="0">
+              <a:rPr lang="en-US" sz="1000" dirty="0">
                 <a:solidFill>
                   <a:srgbClr val="E6E6E6"/>
                 </a:solidFill>
@@ -10683,7 +10683,7 @@
               <a:buNone/>
             </a:pPr>
             <a:r>
-              <a:rPr lang="en-US" sz="1100" dirty="0">
+              <a:rPr lang="en-US" sz="1000" dirty="0">
                 <a:solidFill>
                   <a:srgbClr val="E6E6E6"/>
                 </a:solidFill>
@@ -10701,7 +10701,7 @@
               <a:buNone/>
             </a:pPr>
             <a:r>
-              <a:rPr lang="en-US" sz="1100" dirty="0">
+              <a:rPr lang="en-US" sz="1000" dirty="0">
                 <a:solidFill>
                   <a:srgbClr val="E6E6E6"/>
                 </a:solidFill>
@@ -10719,7 +10719,7 @@
               <a:buNone/>
             </a:pPr>
             <a:r>
-              <a:rPr lang="en-US" sz="1100" dirty="0">
+              <a:rPr lang="en-US" sz="1000" dirty="0">
                 <a:solidFill>
                   <a:srgbClr val="E6E6E6"/>
                 </a:solidFill>
@@ -10737,7 +10737,7 @@
               <a:buNone/>
             </a:pPr>
             <a:r>
-              <a:rPr lang="en-US" sz="1100" dirty="0">
+              <a:rPr lang="en-US" sz="1000" dirty="0">
                 <a:solidFill>
                   <a:srgbClr val="E6E6E6"/>
                 </a:solidFill>
@@ -10755,7 +10755,7 @@
               <a:buNone/>
             </a:pPr>
             <a:r>
-              <a:rPr lang="en-US" sz="1100" dirty="0">
+              <a:rPr lang="en-US" sz="1000" dirty="0">
                 <a:solidFill>
                   <a:srgbClr val="E6E6E6"/>
                 </a:solidFill>
@@ -10773,7 +10773,7 @@
               <a:buNone/>
             </a:pPr>
             <a:r>
-              <a:rPr lang="en-US" sz="1100" dirty="0">
+              <a:rPr lang="en-US" sz="1000" dirty="0">
                 <a:solidFill>
                   <a:srgbClr val="E6E6E6"/>
                 </a:solidFill>
@@ -10791,7 +10791,7 @@
               <a:buNone/>
             </a:pPr>
             <a:r>
-              <a:rPr lang="en-US" sz="1100" dirty="0">
+              <a:rPr lang="en-US" sz="1000" dirty="0">
                 <a:solidFill>
                   <a:srgbClr val="E6E6E6"/>
                 </a:solidFill>
@@ -10809,7 +10809,7 @@
               <a:buNone/>
             </a:pPr>
             <a:r>
-              <a:rPr lang="en-US" sz="1100" dirty="0">
+              <a:rPr lang="en-US" sz="1000" dirty="0">
                 <a:solidFill>
                   <a:srgbClr val="E6E6E6"/>
                 </a:solidFill>
@@ -10827,7 +10827,7 @@
               <a:buNone/>
             </a:pPr>
             <a:r>
-              <a:rPr lang="en-US" sz="1100" dirty="0">
+              <a:rPr lang="en-US" sz="1000" dirty="0">
                 <a:solidFill>
                   <a:srgbClr val="E6E6E6"/>
                 </a:solidFill>
@@ -10845,7 +10845,7 @@
               <a:buNone/>
             </a:pPr>
             <a:r>
-              <a:rPr lang="en-US" sz="1100" dirty="0">
+              <a:rPr lang="en-US" sz="1000" dirty="0">
                 <a:solidFill>
                   <a:srgbClr val="E6E6E6"/>
                 </a:solidFill>
@@ -10863,7 +10863,7 @@
               <a:buNone/>
             </a:pPr>
             <a:r>
-              <a:rPr lang="en-US" sz="1100" dirty="0">
+              <a:rPr lang="en-US" sz="1000" dirty="0">
                 <a:solidFill>
                   <a:srgbClr val="E6E6E6"/>
                 </a:solidFill>
@@ -10881,7 +10881,7 @@
               <a:buNone/>
             </a:pPr>
             <a:r>
-              <a:rPr lang="en-US" sz="1100" dirty="0">
+              <a:rPr lang="en-US" sz="1000" dirty="0">
                 <a:solidFill>
                   <a:srgbClr val="E6E6E6"/>
                 </a:solidFill>
@@ -10899,7 +10899,7 @@
               <a:buNone/>
             </a:pPr>
             <a:r>
-              <a:rPr lang="en-US" sz="1100" dirty="0">
+              <a:rPr lang="en-US" sz="1000" dirty="0">
                 <a:solidFill>
                   <a:srgbClr val="E6E6E6"/>
                 </a:solidFill>
@@ -10917,7 +10917,7 @@
               <a:buNone/>
             </a:pPr>
             <a:r>
-              <a:rPr lang="en-US" sz="1100" dirty="0">
+              <a:rPr lang="en-US" sz="1000" dirty="0">
                 <a:solidFill>
                   <a:srgbClr val="E6E6E6"/>
                 </a:solidFill>
@@ -10935,7 +10935,7 @@
               <a:buNone/>
             </a:pPr>
             <a:r>
-              <a:rPr lang="en-US" sz="1100" dirty="0">
+              <a:rPr lang="en-US" sz="1000" dirty="0">
                 <a:solidFill>
                   <a:srgbClr val="E6E6E6"/>
                 </a:solidFill>
@@ -10953,7 +10953,7 @@
               <a:buNone/>
             </a:pPr>
             <a:r>
-              <a:rPr lang="en-US" sz="1100" dirty="0">
+              <a:rPr lang="en-US" sz="1000" dirty="0">
                 <a:solidFill>
                   <a:srgbClr val="E6E6E6"/>
                 </a:solidFill>
@@ -10971,7 +10971,7 @@
               <a:buNone/>
             </a:pPr>
             <a:r>
-              <a:rPr lang="en-US" sz="1100" dirty="0">
+              <a:rPr lang="en-US" sz="1000" dirty="0">
                 <a:solidFill>
                   <a:srgbClr val="E6E6E6"/>
                 </a:solidFill>
@@ -10989,7 +10989,7 @@
               <a:buNone/>
             </a:pPr>
             <a:r>
-              <a:rPr lang="en-US" sz="1100" dirty="0">
+              <a:rPr lang="en-US" sz="1000" dirty="0">
                 <a:solidFill>
                   <a:srgbClr val="E6E6E6"/>
                 </a:solidFill>
@@ -11000,7 +11000,7 @@
               <a:t>}
 </a:t>
             </a:r>
-            <a:endParaRPr lang="en-US" sz="1100" dirty="0"/>
+            <a:endParaRPr lang="en-US" sz="1000" dirty="0"/>
           </a:p>
         </p:txBody>
       </p:sp>
@@ -11012,7 +11012,7 @@
         </p:nvSpPr>
         <p:spPr>
           <a:xfrm>
-            <a:off x="566928" y="5943600"/>
+            <a:off x="566928" y="6153912"/>
             <a:ext cx="11055096" cy="310896"/>
           </a:xfrm>
           <a:prstGeom prst="rect">
@@ -11249,7 +11249,7 @@
                 <a:ea typeface="Red Hat Text" pitchFamily="34" charset="-122"/>
                 <a:cs typeface="Red Hat Text" pitchFamily="34" charset="-120"/>
               </a:rPr>
-              <a:t>CarrierGatewayGenerator implements IIncrementalGenerator and runs inside the compiler itself, turning a plain-text carriers.manifest file into real gateway classes before the project's own code ever compiles.</a:t>
+              <a:t>CarrierGatewayGenerator implements IIncrementalGenerator and runs inside the compiler, turning a plain-text carriers.manifest into real gateway classes at build time.</a:t>
             </a:r>
             <a:endParaRPr lang="en-US" sz="1550" dirty="0"/>
           </a:p>
@@ -11297,7 +11297,7 @@
                 <a:ea typeface="Red Hat Text" pitchFamily="34" charset="-122"/>
                 <a:cs typeface="Red Hat Text" pitchFamily="34" charset="-120"/>
               </a:rPr>
-              <a:t>EquatableArray&lt;CarrierEntry&gt; lets the incremental pipeline compare an unchanged manifest by value, so an editor keystroke that does not touch the manifest reruns nothing; GeneratedCarrierRegistry.Find is called directly, with no reflection scan involved.</a:t>
+              <a:t>EquatableArray&lt;CarrierEntry&gt; lets the pipeline compare an unchanged manifest by value, so an edit elsewhere reruns nothing; GeneratedCarrierRegistry.Find needs no reflection scan.</a:t>
             </a:r>
             <a:endParaRPr lang="en-US" sz="1550" dirty="0"/>
           </a:p>
@@ -16327,7 +16327,7 @@
                           <a:ea typeface="Red Hat Text" pitchFamily="34" charset="-122"/>
                           <a:cs typeface="Red Hat Text" pitchFamily="34" charset="-120"/>
                         </a:rPr>
-                        <a:t>Recursive value equality, a required property, and a nullable string? retire the Null-Object reflex for a genuinely absent value.</a:t>
+                        <a:t>Recursive value equality, a required property, and a nullable string? retire the Null-Object reflex for an absent value.</a:t>
                       </a:r>
                       <a:endParaRPr lang="en-US" sz="1300" dirty="0">
                         <a:latin typeface="Red Hat Text" charset="0"/>
@@ -17551,8 +17551,8 @@
         </p:nvSpPr>
         <p:spPr>
           <a:xfrm>
-            <a:off x="566928" y="1691640"/>
-            <a:ext cx="11055096" cy="4251960"/>
+            <a:off x="566928" y="1572768"/>
+            <a:ext cx="11055096" cy="4526280"/>
           </a:xfrm>
           <a:prstGeom prst="rect">
             <a:avLst/>
@@ -17576,8 +17576,8 @@
         </p:nvSpPr>
         <p:spPr>
           <a:xfrm>
-            <a:off x="749808" y="1783080"/>
-            <a:ext cx="10689336" cy="4069080"/>
+            <a:off x="749808" y="1664208"/>
+            <a:ext cx="10689336" cy="4343400"/>
           </a:xfrm>
           <a:prstGeom prst="rect">
             <a:avLst/>
@@ -17596,7 +17596,7 @@
               <a:buNone/>
             </a:pPr>
             <a:r>
-              <a:rPr lang="en-US" sz="1100" dirty="0">
+              <a:rPr lang="en-US" sz="1000" dirty="0">
                 <a:solidFill>
                   <a:srgbClr val="E6E6E6"/>
                 </a:solidFill>
@@ -17614,7 +17614,7 @@
               <a:buNone/>
             </a:pPr>
             <a:r>
-              <a:rPr lang="en-US" sz="1100" dirty="0">
+              <a:rPr lang="en-US" sz="1000" dirty="0">
                 <a:solidFill>
                   <a:srgbClr val="E6E6E6"/>
                 </a:solidFill>
@@ -17632,7 +17632,7 @@
               <a:buNone/>
             </a:pPr>
             <a:r>
-              <a:rPr lang="en-US" sz="1100" dirty="0">
+              <a:rPr lang="en-US" sz="1000" dirty="0">
                 <a:solidFill>
                   <a:srgbClr val="E6E6E6"/>
                 </a:solidFill>
@@ -17650,7 +17650,7 @@
               <a:buNone/>
             </a:pPr>
             <a:r>
-              <a:rPr lang="en-US" sz="1100" dirty="0">
+              <a:rPr lang="en-US" sz="1000" dirty="0">
                 <a:solidFill>
                   <a:srgbClr val="E6E6E6"/>
                 </a:solidFill>
@@ -17668,7 +17668,7 @@
               <a:buNone/>
             </a:pPr>
             <a:r>
-              <a:rPr lang="en-US" sz="1100" dirty="0">
+              <a:rPr lang="en-US" sz="1000" dirty="0">
                 <a:solidFill>
                   <a:srgbClr val="E6E6E6"/>
                 </a:solidFill>
@@ -17686,7 +17686,7 @@
               <a:buNone/>
             </a:pPr>
             <a:r>
-              <a:rPr lang="en-US" sz="1100" dirty="0">
+              <a:rPr lang="en-US" sz="1000" dirty="0">
                 <a:solidFill>
                   <a:srgbClr val="E6E6E6"/>
                 </a:solidFill>
@@ -17704,7 +17704,7 @@
               <a:buNone/>
             </a:pPr>
             <a:r>
-              <a:rPr lang="en-US" sz="1100" dirty="0">
+              <a:rPr lang="en-US" sz="1000" dirty="0">
                 <a:solidFill>
                   <a:srgbClr val="E6E6E6"/>
                 </a:solidFill>
@@ -17722,7 +17722,7 @@
               <a:buNone/>
             </a:pPr>
             <a:r>
-              <a:rPr lang="en-US" sz="1100" dirty="0">
+              <a:rPr lang="en-US" sz="1000" dirty="0">
                 <a:solidFill>
                   <a:srgbClr val="E6E6E6"/>
                 </a:solidFill>
@@ -17740,7 +17740,7 @@
               <a:buNone/>
             </a:pPr>
             <a:r>
-              <a:rPr lang="en-US" sz="1100" dirty="0">
+              <a:rPr lang="en-US" sz="1000" dirty="0">
                 <a:solidFill>
                   <a:srgbClr val="E6E6E6"/>
                 </a:solidFill>
@@ -17758,7 +17758,7 @@
               <a:buNone/>
             </a:pPr>
             <a:r>
-              <a:rPr lang="en-US" sz="1100" dirty="0">
+              <a:rPr lang="en-US" sz="1000" dirty="0">
                 <a:solidFill>
                   <a:srgbClr val="E6E6E6"/>
                 </a:solidFill>
@@ -17776,7 +17776,7 @@
               <a:buNone/>
             </a:pPr>
             <a:r>
-              <a:rPr lang="en-US" sz="1100" dirty="0">
+              <a:rPr lang="en-US" sz="1000" dirty="0">
                 <a:solidFill>
                   <a:srgbClr val="E6E6E6"/>
                 </a:solidFill>
@@ -17794,7 +17794,7 @@
               <a:buNone/>
             </a:pPr>
             <a:r>
-              <a:rPr lang="en-US" sz="1100" dirty="0">
+              <a:rPr lang="en-US" sz="1000" dirty="0">
                 <a:solidFill>
                   <a:srgbClr val="E6E6E6"/>
                 </a:solidFill>
@@ -17812,7 +17812,7 @@
               <a:buNone/>
             </a:pPr>
             <a:r>
-              <a:rPr lang="en-US" sz="1100" dirty="0">
+              <a:rPr lang="en-US" sz="1000" dirty="0">
                 <a:solidFill>
                   <a:srgbClr val="E6E6E6"/>
                 </a:solidFill>
@@ -17830,7 +17830,7 @@
               <a:buNone/>
             </a:pPr>
             <a:r>
-              <a:rPr lang="en-US" sz="1100" dirty="0">
+              <a:rPr lang="en-US" sz="1000" dirty="0">
                 <a:solidFill>
                   <a:srgbClr val="E6E6E6"/>
                 </a:solidFill>
@@ -17848,7 +17848,7 @@
               <a:buNone/>
             </a:pPr>
             <a:r>
-              <a:rPr lang="en-US" sz="1100" dirty="0">
+              <a:rPr lang="en-US" sz="1000" dirty="0">
                 <a:solidFill>
                   <a:srgbClr val="E6E6E6"/>
                 </a:solidFill>
@@ -17866,7 +17866,7 @@
               <a:buNone/>
             </a:pPr>
             <a:r>
-              <a:rPr lang="en-US" sz="1100" dirty="0">
+              <a:rPr lang="en-US" sz="1000" dirty="0">
                 <a:solidFill>
                   <a:srgbClr val="E6E6E6"/>
                 </a:solidFill>
@@ -17884,7 +17884,7 @@
               <a:buNone/>
             </a:pPr>
             <a:r>
-              <a:rPr lang="en-US" sz="1100" dirty="0">
+              <a:rPr lang="en-US" sz="1000" dirty="0">
                 <a:solidFill>
                   <a:srgbClr val="E6E6E6"/>
                 </a:solidFill>
@@ -17902,7 +17902,7 @@
               <a:buNone/>
             </a:pPr>
             <a:r>
-              <a:rPr lang="en-US" sz="1100" dirty="0">
+              <a:rPr lang="en-US" sz="1000" dirty="0">
                 <a:solidFill>
                   <a:srgbClr val="E6E6E6"/>
                 </a:solidFill>
@@ -17920,7 +17920,7 @@
               <a:buNone/>
             </a:pPr>
             <a:r>
-              <a:rPr lang="en-US" sz="1100" dirty="0">
+              <a:rPr lang="en-US" sz="1000" dirty="0">
                 <a:solidFill>
                   <a:srgbClr val="E6E6E6"/>
                 </a:solidFill>
@@ -17938,7 +17938,7 @@
               <a:buNone/>
             </a:pPr>
             <a:r>
-              <a:rPr lang="en-US" sz="1100" dirty="0">
+              <a:rPr lang="en-US" sz="1000" dirty="0">
                 <a:solidFill>
                   <a:srgbClr val="E6E6E6"/>
                 </a:solidFill>
@@ -17956,7 +17956,7 @@
               <a:buNone/>
             </a:pPr>
             <a:r>
-              <a:rPr lang="en-US" sz="1100" dirty="0">
+              <a:rPr lang="en-US" sz="1000" dirty="0">
                 <a:solidFill>
                   <a:srgbClr val="E6E6E6"/>
                 </a:solidFill>
@@ -17974,7 +17974,7 @@
               <a:buNone/>
             </a:pPr>
             <a:r>
-              <a:rPr lang="en-US" sz="1100" dirty="0">
+              <a:rPr lang="en-US" sz="1000" dirty="0">
                 <a:solidFill>
                   <a:srgbClr val="E6E6E6"/>
                 </a:solidFill>
@@ -17992,7 +17992,7 @@
               <a:buNone/>
             </a:pPr>
             <a:r>
-              <a:rPr lang="en-US" sz="1100" dirty="0">
+              <a:rPr lang="en-US" sz="1000" dirty="0">
                 <a:solidFill>
                   <a:srgbClr val="E6E6E6"/>
                 </a:solidFill>
@@ -18010,7 +18010,7 @@
               <a:buNone/>
             </a:pPr>
             <a:r>
-              <a:rPr lang="en-US" sz="1100" dirty="0">
+              <a:rPr lang="en-US" sz="1000" dirty="0">
                 <a:solidFill>
                   <a:srgbClr val="E6E6E6"/>
                 </a:solidFill>
@@ -18028,7 +18028,7 @@
               <a:buNone/>
             </a:pPr>
             <a:r>
-              <a:rPr lang="en-US" sz="1100" dirty="0">
+              <a:rPr lang="en-US" sz="1000" dirty="0">
                 <a:solidFill>
                   <a:srgbClr val="E6E6E6"/>
                 </a:solidFill>
@@ -18046,7 +18046,7 @@
               <a:buNone/>
             </a:pPr>
             <a:r>
-              <a:rPr lang="en-US" sz="1100" dirty="0">
+              <a:rPr lang="en-US" sz="1000" dirty="0">
                 <a:solidFill>
                   <a:srgbClr val="E6E6E6"/>
                 </a:solidFill>
@@ -18064,7 +18064,7 @@
               <a:buNone/>
             </a:pPr>
             <a:r>
-              <a:rPr lang="en-US" sz="1100" dirty="0">
+              <a:rPr lang="en-US" sz="1000" dirty="0">
                 <a:solidFill>
                   <a:srgbClr val="8FB98F"/>
                 </a:solidFill>
@@ -18082,7 +18082,7 @@
               <a:buNone/>
             </a:pPr>
             <a:r>
-              <a:rPr lang="en-US" sz="1100" dirty="0">
+              <a:rPr lang="en-US" sz="1000" dirty="0">
                 <a:solidFill>
                   <a:srgbClr val="E6E6E6"/>
                 </a:solidFill>
@@ -18100,7 +18100,7 @@
               <a:buNone/>
             </a:pPr>
             <a:r>
-              <a:rPr lang="en-US" sz="1100" dirty="0">
+              <a:rPr lang="en-US" sz="1000" dirty="0">
                 <a:solidFill>
                   <a:srgbClr val="E6E6E6"/>
                 </a:solidFill>
@@ -18111,7 +18111,7 @@
               <a:t>}
 </a:t>
             </a:r>
-            <a:endParaRPr lang="en-US" sz="1100" dirty="0"/>
+            <a:endParaRPr lang="en-US" sz="1000" dirty="0"/>
           </a:p>
         </p:txBody>
       </p:sp>
@@ -18123,7 +18123,7 @@
         </p:nvSpPr>
         <p:spPr>
           <a:xfrm>
-            <a:off x="566928" y="5943600"/>
+            <a:off x="566928" y="6153912"/>
             <a:ext cx="11055096" cy="310896"/>
           </a:xfrm>
           <a:prstGeom prst="rect">
@@ -18148,7 +18148,7 @@
                 <a:ea typeface="Red Hat Text" pitchFamily="34" charset="-122"/>
                 <a:cs typeface="Red Hat Text" pitchFamily="34" charset="-120"/>
               </a:rPr>
-              <a:t>A readonly ref struct can hold a ReadOnlySpan&lt;char&gt; field; Slice and TryParse read the segment with CultureInfo.InvariantCulture and allocate nothing on a successful parse.</a:t>
+              <a:t>A readonly ref struct can hold a ReadOnlySpan&lt;char&gt; field; Slice and TryParse read it with no allocation on a successful parse.</a:t>
             </a:r>
             <a:endParaRPr lang="en-US" sz="1300" dirty="0"/>
           </a:p>
@@ -18360,7 +18360,7 @@
                 <a:ea typeface="Red Hat Text" pitchFamily="34" charset="-122"/>
                 <a:cs typeface="Red Hat Text" pitchFamily="34" charset="-120"/>
               </a:rPr>
-              <a:t>A sealed record Consignment gets recursive value equality for free: two independently built consignments with the same Route, Weight, and reference number compare equal.</a:t>
+              <a:t>A sealed record Consignment gets recursive value equality from the compiler: two independently built consignments with the same Route, Weight, and reference number compare equal.</a:t>
             </a:r>
             <a:endParaRPr lang="en-US" sz="1550" dirty="0"/>
           </a:p>
@@ -19235,8 +19235,8 @@
         </p:nvSpPr>
         <p:spPr>
           <a:xfrm>
-            <a:off x="566928" y="1691640"/>
-            <a:ext cx="11055096" cy="4251960"/>
+            <a:off x="566928" y="1572768"/>
+            <a:ext cx="11055096" cy="4526280"/>
           </a:xfrm>
           <a:prstGeom prst="rect">
             <a:avLst/>
@@ -19260,8 +19260,8 @@
         </p:nvSpPr>
         <p:spPr>
           <a:xfrm>
-            <a:off x="749808" y="1783080"/>
-            <a:ext cx="10689336" cy="4069080"/>
+            <a:off x="749808" y="1664208"/>
+            <a:ext cx="10689336" cy="4343400"/>
           </a:xfrm>
           <a:prstGeom prst="rect">
             <a:avLst/>
@@ -19280,7 +19280,7 @@
               <a:buNone/>
             </a:pPr>
             <a:r>
-              <a:rPr lang="en-US" sz="1100" dirty="0">
+              <a:rPr lang="en-US" sz="1000" dirty="0">
                 <a:solidFill>
                   <a:srgbClr val="E6E6E6"/>
                 </a:solidFill>
@@ -19298,7 +19298,7 @@
               <a:buNone/>
             </a:pPr>
             <a:r>
-              <a:rPr lang="en-US" sz="1100" dirty="0">
+              <a:rPr lang="en-US" sz="1000" dirty="0">
                 <a:solidFill>
                   <a:srgbClr val="E6E6E6"/>
                 </a:solidFill>
@@ -19316,7 +19316,7 @@
               <a:buNone/>
             </a:pPr>
             <a:r>
-              <a:rPr lang="en-US" sz="1100" dirty="0">
+              <a:rPr lang="en-US" sz="1000" dirty="0">
                 <a:solidFill>
                   <a:srgbClr val="E6E6E6"/>
                 </a:solidFill>
@@ -19334,7 +19334,7 @@
               <a:buNone/>
             </a:pPr>
             <a:r>
-              <a:rPr lang="en-US" sz="1100" dirty="0">
+              <a:rPr lang="en-US" sz="1000" dirty="0">
                 <a:solidFill>
                   <a:srgbClr val="E6E6E6"/>
                 </a:solidFill>
@@ -19352,7 +19352,7 @@
               <a:buNone/>
             </a:pPr>
             <a:r>
-              <a:rPr lang="en-US" sz="1100" dirty="0">
+              <a:rPr lang="en-US" sz="1000" dirty="0">
                 <a:solidFill>
                   <a:srgbClr val="E6E6E6"/>
                 </a:solidFill>
@@ -19370,7 +19370,7 @@
               <a:buNone/>
             </a:pPr>
             <a:r>
-              <a:rPr lang="en-US" sz="1100" dirty="0">
+              <a:rPr lang="en-US" sz="1000" dirty="0">
                 <a:solidFill>
                   <a:srgbClr val="E6E6E6"/>
                 </a:solidFill>
@@ -19388,7 +19388,7 @@
               <a:buNone/>
             </a:pPr>
             <a:r>
-              <a:rPr lang="en-US" sz="1100" dirty="0">
+              <a:rPr lang="en-US" sz="1000" dirty="0">
                 <a:solidFill>
                   <a:srgbClr val="E6E6E6"/>
                 </a:solidFill>
@@ -19406,7 +19406,7 @@
               <a:buNone/>
             </a:pPr>
             <a:r>
-              <a:rPr lang="en-US" sz="1100" dirty="0">
+              <a:rPr lang="en-US" sz="1000" dirty="0">
                 <a:solidFill>
                   <a:srgbClr val="8FB98F"/>
                 </a:solidFill>
@@ -19424,7 +19424,7 @@
               <a:buNone/>
             </a:pPr>
             <a:r>
-              <a:rPr lang="en-US" sz="1100" dirty="0">
+              <a:rPr lang="en-US" sz="1000" dirty="0">
                 <a:solidFill>
                   <a:srgbClr val="E6E6E6"/>
                 </a:solidFill>
@@ -19442,7 +19442,7 @@
               <a:buNone/>
             </a:pPr>
             <a:r>
-              <a:rPr lang="en-US" sz="1100" dirty="0">
+              <a:rPr lang="en-US" sz="1000" dirty="0">
                 <a:solidFill>
                   <a:srgbClr val="E6E6E6"/>
                 </a:solidFill>
@@ -19460,7 +19460,7 @@
               <a:buNone/>
             </a:pPr>
             <a:r>
-              <a:rPr lang="en-US" sz="1100" dirty="0">
+              <a:rPr lang="en-US" sz="1000" dirty="0">
                 <a:solidFill>
                   <a:srgbClr val="E6E6E6"/>
                 </a:solidFill>
@@ -19478,7 +19478,7 @@
               <a:buNone/>
             </a:pPr>
             <a:r>
-              <a:rPr lang="en-US" sz="1100" dirty="0">
+              <a:rPr lang="en-US" sz="1000" dirty="0">
                 <a:solidFill>
                   <a:srgbClr val="E6E6E6"/>
                 </a:solidFill>
@@ -19496,7 +19496,7 @@
               <a:buNone/>
             </a:pPr>
             <a:r>
-              <a:rPr lang="en-US" sz="1100" dirty="0">
+              <a:rPr lang="en-US" sz="1000" dirty="0">
                 <a:solidFill>
                   <a:srgbClr val="E6E6E6"/>
                 </a:solidFill>
@@ -19514,7 +19514,7 @@
               <a:buNone/>
             </a:pPr>
             <a:r>
-              <a:rPr lang="en-US" sz="1100" dirty="0">
+              <a:rPr lang="en-US" sz="1000" dirty="0">
                 <a:solidFill>
                   <a:srgbClr val="E6E6E6"/>
                 </a:solidFill>
@@ -19532,7 +19532,7 @@
               <a:buNone/>
             </a:pPr>
             <a:r>
-              <a:rPr lang="en-US" sz="1100" dirty="0">
+              <a:rPr lang="en-US" sz="1000" dirty="0">
                 <a:solidFill>
                   <a:srgbClr val="E6E6E6"/>
                 </a:solidFill>
@@ -19550,7 +19550,7 @@
               <a:buNone/>
             </a:pPr>
             <a:r>
-              <a:rPr lang="en-US" sz="1100" dirty="0">
+              <a:rPr lang="en-US" sz="1000" dirty="0">
                 <a:solidFill>
                   <a:srgbClr val="E6E6E6"/>
                 </a:solidFill>
@@ -19568,7 +19568,7 @@
               <a:buNone/>
             </a:pPr>
             <a:r>
-              <a:rPr lang="en-US" sz="1100" dirty="0">
+              <a:rPr lang="en-US" sz="1000" dirty="0">
                 <a:solidFill>
                   <a:srgbClr val="E6E6E6"/>
                 </a:solidFill>
@@ -19586,7 +19586,7 @@
               <a:buNone/>
             </a:pPr>
             <a:r>
-              <a:rPr lang="en-US" sz="1100" dirty="0">
+              <a:rPr lang="en-US" sz="1000" dirty="0">
                 <a:solidFill>
                   <a:srgbClr val="E6E6E6"/>
                 </a:solidFill>
@@ -19604,7 +19604,7 @@
               <a:buNone/>
             </a:pPr>
             <a:r>
-              <a:rPr lang="en-US" sz="1100" dirty="0">
+              <a:rPr lang="en-US" sz="1000" dirty="0">
                 <a:solidFill>
                   <a:srgbClr val="E6E6E6"/>
                 </a:solidFill>
@@ -19622,7 +19622,7 @@
               <a:buNone/>
             </a:pPr>
             <a:r>
-              <a:rPr lang="en-US" sz="1100" dirty="0">
+              <a:rPr lang="en-US" sz="1000" dirty="0">
                 <a:solidFill>
                   <a:srgbClr val="E6E6E6"/>
                 </a:solidFill>
@@ -19640,7 +19640,7 @@
               <a:buNone/>
             </a:pPr>
             <a:r>
-              <a:rPr lang="en-US" sz="1100" dirty="0">
+              <a:rPr lang="en-US" sz="1000" dirty="0">
                 <a:solidFill>
                   <a:srgbClr val="E6E6E6"/>
                 </a:solidFill>
@@ -19658,7 +19658,7 @@
               <a:buNone/>
             </a:pPr>
             <a:r>
-              <a:rPr lang="en-US" sz="1100" dirty="0">
+              <a:rPr lang="en-US" sz="1000" dirty="0">
                 <a:solidFill>
                   <a:srgbClr val="E6E6E6"/>
                 </a:solidFill>
@@ -19676,7 +19676,7 @@
               <a:buNone/>
             </a:pPr>
             <a:r>
-              <a:rPr lang="en-US" sz="1100" dirty="0">
+              <a:rPr lang="en-US" sz="1000" dirty="0">
                 <a:solidFill>
                   <a:srgbClr val="E6E6E6"/>
                 </a:solidFill>
@@ -19694,7 +19694,7 @@
               <a:buNone/>
             </a:pPr>
             <a:r>
-              <a:rPr lang="en-US" sz="1100" dirty="0">
+              <a:rPr lang="en-US" sz="1000" dirty="0">
                 <a:solidFill>
                   <a:srgbClr val="E6E6E6"/>
                 </a:solidFill>
@@ -19712,7 +19712,7 @@
               <a:buNone/>
             </a:pPr>
             <a:r>
-              <a:rPr lang="en-US" sz="1100" dirty="0">
+              <a:rPr lang="en-US" sz="1000" dirty="0">
                 <a:solidFill>
                   <a:srgbClr val="E6E6E6"/>
                 </a:solidFill>
@@ -19730,7 +19730,7 @@
               <a:buNone/>
             </a:pPr>
             <a:r>
-              <a:rPr lang="en-US" sz="1100" dirty="0">
+              <a:rPr lang="en-US" sz="1000" dirty="0">
                 <a:solidFill>
                   <a:srgbClr val="E6E6E6"/>
                 </a:solidFill>
@@ -19748,7 +19748,7 @@
               <a:buNone/>
             </a:pPr>
             <a:r>
-              <a:rPr lang="en-US" sz="1100" dirty="0">
+              <a:rPr lang="en-US" sz="1000" dirty="0">
                 <a:solidFill>
                   <a:srgbClr val="E6E6E6"/>
                 </a:solidFill>
@@ -19759,7 +19759,7 @@
               <a:t>}
 </a:t>
             </a:r>
-            <a:endParaRPr lang="en-US" sz="1100" dirty="0"/>
+            <a:endParaRPr lang="en-US" sz="1000" dirty="0"/>
           </a:p>
         </p:txBody>
       </p:sp>
@@ -19771,7 +19771,7 @@
         </p:nvSpPr>
         <p:spPr>
           <a:xfrm>
-            <a:off x="566928" y="5943600"/>
+            <a:off x="566928" y="6153912"/>
             <a:ext cx="11055096" cy="310896"/>
           </a:xfrm>
           <a:prstGeom prst="rect">
@@ -19796,7 +19796,7 @@
                 <a:ea typeface="Red Hat Text" pitchFamily="34" charset="-122"/>
                 <a:cs typeface="Red Hat Text" pitchFamily="34" charset="-120"/>
               </a:rPr>
-              <a:t>ObjectDisposedException.ThrowIf guards every call after disposal; DisposeAsync returns a ValueTask and flows ConfigureAwait(false) through library code.</a:t>
+              <a:t>ObjectDisposedException.ThrowIf guards every call after disposal; DisposeAsync returns a ValueTask with ConfigureAwait(false).</a:t>
             </a:r>
             <a:endParaRPr lang="en-US" sz="1300" dirty="0"/>
           </a:p>

</xml_diff>